<commit_message>
Take TMK product shots from the supplier's own quotation
The price-comparison workbook only has TMK as multi-flavour line-ups, so each
flavour had to be sliced out of a ~130px strip, which left ragged crops and, on
Double Roll, two half-boxes overlapping.

The KOKIRI quotation carries the same products as separate, cleanly framed
images. Resolution is the same order (41-117px), but the framing is consistent
and Double Roll and Mini are markedly better. The quotation also confirms the
flavour mapping: its row order matches the flavour list printed beside it, and
that ordering matches the colour code the slices were assigned by.

The PDF is not committed — it carries the supplier's bank details — so
prep_images.py reads it from a configured path and skips the TMK shots when it
is absent.

Co-Authored-By: Claude Opus 5 <noreply@anthropic.com>
Claude-Session: https://claude.ai/code/session_01PJ98fwASZjvQEuyWRiRoCu
</commit_message>
<xml_diff>
--- a/presentation/Постачальники_снеків_собівартість.pptx
+++ b/presentation/Постачальники_снеків_собівартість.pptx
@@ -3632,8 +3632,8 @@
         </p:blipFill>
         <p:spPr>
           <a:xfrm>
-            <a:off x="6016752" y="3646424"/>
-            <a:ext cx="548640" cy="955040"/>
+            <a:off x="6016752" y="3651504"/>
+            <a:ext cx="548640" cy="944880"/>
           </a:xfrm>
           <a:prstGeom prst="rect">
             <a:avLst/>
@@ -26490,8 +26490,8 @@
         </p:nvSpPr>
         <p:spPr>
           <a:xfrm>
-            <a:off x="5486400" y="1304544"/>
-            <a:ext cx="1572767" cy="1347216"/>
+            <a:off x="5486400" y="1395984"/>
+            <a:ext cx="1572767" cy="1255776"/>
           </a:xfrm>
           <a:prstGeom prst="rect">
             <a:avLst/>
@@ -26540,8 +26540,8 @@
         </p:blipFill>
         <p:spPr>
           <a:xfrm>
-            <a:off x="5998464" y="1500632"/>
-            <a:ext cx="548640" cy="955040"/>
+            <a:off x="5998464" y="1551432"/>
+            <a:ext cx="548640" cy="944880"/>
           </a:xfrm>
           <a:prstGeom prst="rect">
             <a:avLst/>
@@ -26556,8 +26556,8 @@
         </p:nvSpPr>
         <p:spPr>
           <a:xfrm>
-            <a:off x="7205472" y="1304544"/>
-            <a:ext cx="1572767" cy="1347216"/>
+            <a:off x="7205472" y="1395984"/>
+            <a:ext cx="1572767" cy="1255776"/>
           </a:xfrm>
           <a:prstGeom prst="rect">
             <a:avLst/>
@@ -26606,8 +26606,8 @@
         </p:blipFill>
         <p:spPr>
           <a:xfrm>
-            <a:off x="7707376" y="1500632"/>
-            <a:ext cx="568960" cy="955040"/>
+            <a:off x="7722615" y="1551432"/>
+            <a:ext cx="538480" cy="944880"/>
           </a:xfrm>
           <a:prstGeom prst="rect">
             <a:avLst/>
@@ -26623,7 +26623,7 @@
         <p:spPr>
           <a:xfrm>
             <a:off x="5486400" y="2798064"/>
-            <a:ext cx="1572767" cy="1347216"/>
+            <a:ext cx="1572767" cy="1255776"/>
           </a:xfrm>
           <a:prstGeom prst="rect">
             <a:avLst/>
@@ -26672,8 +26672,8 @@
         </p:blipFill>
         <p:spPr>
           <a:xfrm>
-            <a:off x="5998464" y="2994152"/>
-            <a:ext cx="548640" cy="955040"/>
+            <a:off x="6023864" y="2953512"/>
+            <a:ext cx="497840" cy="944880"/>
           </a:xfrm>
           <a:prstGeom prst="rect">
             <a:avLst/>
@@ -26689,7 +26689,7 @@
         <p:spPr>
           <a:xfrm>
             <a:off x="7205472" y="2798064"/>
-            <a:ext cx="1572767" cy="1347216"/>
+            <a:ext cx="1572767" cy="1255776"/>
           </a:xfrm>
           <a:prstGeom prst="rect">
             <a:avLst/>
@@ -26738,8 +26738,8 @@
         </p:blipFill>
         <p:spPr>
           <a:xfrm>
-            <a:off x="7661655" y="2953512"/>
-            <a:ext cx="660400" cy="1036320"/>
+            <a:off x="7580375" y="3009392"/>
+            <a:ext cx="822960" cy="833120"/>
           </a:xfrm>
           <a:prstGeom prst="rect">
             <a:avLst/>
@@ -27148,8 +27148,8 @@
         </p:blipFill>
         <p:spPr>
           <a:xfrm>
-            <a:off x="1074420" y="1305559"/>
-            <a:ext cx="548640" cy="955040"/>
+            <a:off x="1074420" y="1271016"/>
+            <a:ext cx="548640" cy="944880"/>
           </a:xfrm>
           <a:prstGeom prst="rect">
             <a:avLst/>
@@ -27164,7 +27164,7 @@
         </p:nvSpPr>
         <p:spPr>
           <a:xfrm>
-            <a:off x="512064" y="2432303"/>
+            <a:off x="512064" y="2353056"/>
             <a:ext cx="1673351" cy="9144"/>
           </a:xfrm>
           <a:prstGeom prst="rect">
@@ -27206,7 +27206,7 @@
         </p:nvSpPr>
         <p:spPr>
           <a:xfrm>
-            <a:off x="512064" y="2542032"/>
+            <a:off x="512064" y="2462784"/>
             <a:ext cx="1673351" cy="146304"/>
           </a:xfrm>
           <a:prstGeom prst="rect">
@@ -27245,7 +27245,7 @@
         </p:nvSpPr>
         <p:spPr>
           <a:xfrm>
-            <a:off x="512064" y="2724911"/>
+            <a:off x="512064" y="2645664"/>
             <a:ext cx="1673351" cy="402336"/>
           </a:xfrm>
           <a:prstGeom prst="rect">
@@ -27300,7 +27300,7 @@
         </p:nvSpPr>
         <p:spPr>
           <a:xfrm>
-            <a:off x="512064" y="3182111"/>
+            <a:off x="512064" y="3102864"/>
             <a:ext cx="1673351" cy="585216"/>
           </a:xfrm>
           <a:prstGeom prst="rect">
@@ -28066,8 +28066,8 @@
         </p:blipFill>
         <p:spPr>
           <a:xfrm>
-            <a:off x="3213100" y="1305559"/>
-            <a:ext cx="568960" cy="955040"/>
+            <a:off x="3228340" y="1271016"/>
+            <a:ext cx="538480" cy="944880"/>
           </a:xfrm>
           <a:prstGeom prst="rect">
             <a:avLst/>
@@ -28082,7 +28082,7 @@
         </p:nvSpPr>
         <p:spPr>
           <a:xfrm>
-            <a:off x="2660904" y="2432303"/>
+            <a:off x="2660904" y="2353056"/>
             <a:ext cx="1673351" cy="9144"/>
           </a:xfrm>
           <a:prstGeom prst="rect">
@@ -28124,7 +28124,7 @@
         </p:nvSpPr>
         <p:spPr>
           <a:xfrm>
-            <a:off x="2660904" y="2542032"/>
+            <a:off x="2660904" y="2462784"/>
             <a:ext cx="1673351" cy="146304"/>
           </a:xfrm>
           <a:prstGeom prst="rect">
@@ -28163,7 +28163,7 @@
         </p:nvSpPr>
         <p:spPr>
           <a:xfrm>
-            <a:off x="2660904" y="2724911"/>
+            <a:off x="2660904" y="2645664"/>
             <a:ext cx="1673351" cy="402336"/>
           </a:xfrm>
           <a:prstGeom prst="rect">
@@ -28218,7 +28218,7 @@
         </p:nvSpPr>
         <p:spPr>
           <a:xfrm>
-            <a:off x="2660904" y="3182111"/>
+            <a:off x="2660904" y="3102864"/>
             <a:ext cx="1673351" cy="585216"/>
           </a:xfrm>
           <a:prstGeom prst="rect">
@@ -28984,8 +28984,8 @@
         </p:blipFill>
         <p:spPr>
           <a:xfrm>
-            <a:off x="5372100" y="1305559"/>
-            <a:ext cx="548640" cy="955040"/>
+            <a:off x="5397500" y="1271016"/>
+            <a:ext cx="497840" cy="944880"/>
           </a:xfrm>
           <a:prstGeom prst="rect">
             <a:avLst/>
@@ -29000,7 +29000,7 @@
         </p:nvSpPr>
         <p:spPr>
           <a:xfrm>
-            <a:off x="4809744" y="2432303"/>
+            <a:off x="4809744" y="2353056"/>
             <a:ext cx="1673351" cy="9144"/>
           </a:xfrm>
           <a:prstGeom prst="rect">
@@ -29042,7 +29042,7 @@
         </p:nvSpPr>
         <p:spPr>
           <a:xfrm>
-            <a:off x="4809744" y="2542032"/>
+            <a:off x="4809744" y="2462784"/>
             <a:ext cx="1673351" cy="146304"/>
           </a:xfrm>
           <a:prstGeom prst="rect">
@@ -29081,7 +29081,7 @@
         </p:nvSpPr>
         <p:spPr>
           <a:xfrm>
-            <a:off x="4809744" y="2724911"/>
+            <a:off x="4809744" y="2645664"/>
             <a:ext cx="1673351" cy="402336"/>
           </a:xfrm>
           <a:prstGeom prst="rect">
@@ -29136,7 +29136,7 @@
         </p:nvSpPr>
         <p:spPr>
           <a:xfrm>
-            <a:off x="4809744" y="3182111"/>
+            <a:off x="4809744" y="3102864"/>
             <a:ext cx="1673351" cy="585216"/>
           </a:xfrm>
           <a:prstGeom prst="rect">
@@ -29902,8 +29902,8 @@
         </p:blipFill>
         <p:spPr>
           <a:xfrm>
-            <a:off x="7465060" y="1264920"/>
-            <a:ext cx="660400" cy="1036320"/>
+            <a:off x="7383780" y="1326896"/>
+            <a:ext cx="822960" cy="833120"/>
           </a:xfrm>
           <a:prstGeom prst="rect">
             <a:avLst/>
@@ -29918,7 +29918,7 @@
         </p:nvSpPr>
         <p:spPr>
           <a:xfrm>
-            <a:off x="6958584" y="2432303"/>
+            <a:off x="6958584" y="2353056"/>
             <a:ext cx="1673351" cy="9144"/>
           </a:xfrm>
           <a:prstGeom prst="rect">
@@ -29960,7 +29960,7 @@
         </p:nvSpPr>
         <p:spPr>
           <a:xfrm>
-            <a:off x="6958584" y="2542032"/>
+            <a:off x="6958584" y="2462784"/>
             <a:ext cx="1673351" cy="146304"/>
           </a:xfrm>
           <a:prstGeom prst="rect">
@@ -29999,7 +29999,7 @@
         </p:nvSpPr>
         <p:spPr>
           <a:xfrm>
-            <a:off x="6958584" y="2724911"/>
+            <a:off x="6958584" y="2645664"/>
             <a:ext cx="1673351" cy="402336"/>
           </a:xfrm>
           <a:prstGeom prst="rect">
@@ -30054,7 +30054,7 @@
         </p:nvSpPr>
         <p:spPr>
           <a:xfrm>
-            <a:off x="6958584" y="3182111"/>
+            <a:off x="6958584" y="3102864"/>
             <a:ext cx="1673351" cy="585216"/>
           </a:xfrm>
           <a:prstGeom prst="rect">
@@ -31201,8 +31201,8 @@
         </p:blipFill>
         <p:spPr>
           <a:xfrm>
-            <a:off x="1366520" y="1259839"/>
-            <a:ext cx="680720" cy="1046480"/>
+            <a:off x="1275080" y="1271016"/>
+            <a:ext cx="863600" cy="843280"/>
           </a:xfrm>
           <a:prstGeom prst="rect">
             <a:avLst/>
@@ -31217,7 +31217,7 @@
         </p:nvSpPr>
         <p:spPr>
           <a:xfrm>
-            <a:off x="512064" y="2432303"/>
+            <a:off x="512064" y="2251456"/>
             <a:ext cx="2389632" cy="9144"/>
           </a:xfrm>
           <a:prstGeom prst="rect">
@@ -31259,7 +31259,7 @@
         </p:nvSpPr>
         <p:spPr>
           <a:xfrm>
-            <a:off x="512064" y="2542032"/>
+            <a:off x="512064" y="2361184"/>
             <a:ext cx="2389632" cy="146304"/>
           </a:xfrm>
           <a:prstGeom prst="rect">
@@ -31298,7 +31298,7 @@
         </p:nvSpPr>
         <p:spPr>
           <a:xfrm>
-            <a:off x="512064" y="2724911"/>
+            <a:off x="512064" y="2544063"/>
             <a:ext cx="2389632" cy="402336"/>
           </a:xfrm>
           <a:prstGeom prst="rect">
@@ -31353,7 +31353,7 @@
         </p:nvSpPr>
         <p:spPr>
           <a:xfrm>
-            <a:off x="512064" y="3182111"/>
+            <a:off x="512064" y="3001263"/>
             <a:ext cx="2389632" cy="585216"/>
           </a:xfrm>
           <a:prstGeom prst="rect">
@@ -32119,8 +32119,8 @@
         </p:blipFill>
         <p:spPr>
           <a:xfrm>
-            <a:off x="4292600" y="1417319"/>
-            <a:ext cx="558800" cy="731520"/>
+            <a:off x="4302760" y="1337055"/>
+            <a:ext cx="538480" cy="711200"/>
           </a:xfrm>
           <a:prstGeom prst="rect">
             <a:avLst/>
@@ -32135,7 +32135,7 @@
         </p:nvSpPr>
         <p:spPr>
           <a:xfrm>
-            <a:off x="3377184" y="2432303"/>
+            <a:off x="3377184" y="2251456"/>
             <a:ext cx="2389632" cy="9144"/>
           </a:xfrm>
           <a:prstGeom prst="rect">
@@ -32177,7 +32177,7 @@
         </p:nvSpPr>
         <p:spPr>
           <a:xfrm>
-            <a:off x="3377184" y="2542032"/>
+            <a:off x="3377184" y="2361184"/>
             <a:ext cx="2389632" cy="146304"/>
           </a:xfrm>
           <a:prstGeom prst="rect">
@@ -32216,7 +32216,7 @@
         </p:nvSpPr>
         <p:spPr>
           <a:xfrm>
-            <a:off x="3377184" y="2724911"/>
+            <a:off x="3377184" y="2544063"/>
             <a:ext cx="2389632" cy="402336"/>
           </a:xfrm>
           <a:prstGeom prst="rect">
@@ -32271,7 +32271,7 @@
         </p:nvSpPr>
         <p:spPr>
           <a:xfrm>
-            <a:off x="3377184" y="3182111"/>
+            <a:off x="3377184" y="3001263"/>
             <a:ext cx="2389632" cy="585216"/>
           </a:xfrm>
           <a:prstGeom prst="rect">
@@ -33037,8 +33037,8 @@
         </p:blipFill>
         <p:spPr>
           <a:xfrm>
-            <a:off x="7167880" y="1417319"/>
-            <a:ext cx="538480" cy="731520"/>
+            <a:off x="7167880" y="1331976"/>
+            <a:ext cx="538480" cy="721360"/>
           </a:xfrm>
           <a:prstGeom prst="rect">
             <a:avLst/>
@@ -33053,7 +33053,7 @@
         </p:nvSpPr>
         <p:spPr>
           <a:xfrm>
-            <a:off x="6242304" y="2432303"/>
+            <a:off x="6242304" y="2251456"/>
             <a:ext cx="2389632" cy="9144"/>
           </a:xfrm>
           <a:prstGeom prst="rect">
@@ -33095,7 +33095,7 @@
         </p:nvSpPr>
         <p:spPr>
           <a:xfrm>
-            <a:off x="6242304" y="2542032"/>
+            <a:off x="6242304" y="2361184"/>
             <a:ext cx="2389632" cy="146304"/>
           </a:xfrm>
           <a:prstGeom prst="rect">
@@ -33134,7 +33134,7 @@
         </p:nvSpPr>
         <p:spPr>
           <a:xfrm>
-            <a:off x="6242304" y="2724911"/>
+            <a:off x="6242304" y="2544063"/>
             <a:ext cx="2389632" cy="402336"/>
           </a:xfrm>
           <a:prstGeom prst="rect">
@@ -33189,7 +33189,7 @@
         </p:nvSpPr>
         <p:spPr>
           <a:xfrm>
-            <a:off x="6242304" y="3182111"/>
+            <a:off x="6242304" y="3001263"/>
             <a:ext cx="2389632" cy="585216"/>
           </a:xfrm>
           <a:prstGeom prst="rect">
@@ -34336,8 +34336,8 @@
         </p:blipFill>
         <p:spPr>
           <a:xfrm>
-            <a:off x="1432560" y="1417319"/>
-            <a:ext cx="548640" cy="731520"/>
+            <a:off x="1432560" y="1427479"/>
+            <a:ext cx="548640" cy="711200"/>
           </a:xfrm>
           <a:prstGeom prst="rect">
             <a:avLst/>
@@ -35254,8 +35254,8 @@
         </p:blipFill>
         <p:spPr>
           <a:xfrm>
-            <a:off x="4236720" y="1254759"/>
-            <a:ext cx="670560" cy="1056640"/>
+            <a:off x="4251960" y="1264920"/>
+            <a:ext cx="640080" cy="1036320"/>
           </a:xfrm>
           <a:prstGeom prst="rect">
             <a:avLst/>
@@ -36172,8 +36172,8 @@
         </p:blipFill>
         <p:spPr>
           <a:xfrm>
-            <a:off x="7122160" y="1259839"/>
-            <a:ext cx="629920" cy="1046480"/>
+            <a:off x="7117080" y="1270000"/>
+            <a:ext cx="640080" cy="1026160"/>
           </a:xfrm>
           <a:prstGeom prst="rect">
             <a:avLst/>

</xml_diff>